<commit_message>
Update 스무고개 assets, add ZIP slides and PPT category tip
Co-Authored-By: Claude Opus 4.6 (1M context) <noreply@anthropic.com>
</commit_message>
<xml_diff>
--- a/public/downloads/games/twenty-questions/rules.pptx
+++ b/public/downloads/games/twenty-questions/rules.pptx
@@ -21,16 +21,12 @@
   <p:notesSz cx="6858000" cy="9144000"/>
   <p:embeddedFontLst>
     <p:embeddedFont>
-      <p:font typeface="Jua" charset="1" panose="00000000000000000000"/>
+      <p:font typeface="무궁화 고딕" charset="1" panose="02020603020101020101"/>
       <p:regular r:id="rId17"/>
     </p:embeddedFont>
     <p:embeddedFont>
-      <p:font typeface="TDTD갬성명조" charset="1" panose="02000503000000000000"/>
+      <p:font typeface="무궁화 고딕 Bold" charset="1" panose="02020603020101020101"/>
       <p:regular r:id="rId18"/>
-    </p:embeddedFont>
-    <p:embeddedFont>
-      <p:font typeface="TDTD가온" charset="1" panose="02000503000000000000"/>
-      <p:regular r:id="rId19"/>
     </p:embeddedFont>
   </p:embeddedFontLst>
   <p:defaultTextStyle>
@@ -3148,8 +3144,8 @@
         </p:nvSpPr>
         <p:spPr>
           <a:xfrm rot="0">
-            <a:off x="1028700" y="3892867"/>
-            <a:ext cx="15555091" cy="2200275"/>
+            <a:off x="1028700" y="4178617"/>
+            <a:ext cx="15555091" cy="1914525"/>
           </a:xfrm>
           <a:prstGeom prst="rect">
             <a:avLst/>
@@ -3171,10 +3167,10 @@
                 <a:solidFill>
                   <a:srgbClr val="FFFAEF"/>
                 </a:solidFill>
-                <a:latin typeface="Jua"/>
-                <a:ea typeface="Jua"/>
-                <a:cs typeface="Jua"/>
-                <a:sym typeface="Jua"/>
+                <a:latin typeface="무궁화 고딕"/>
+                <a:ea typeface="무궁화 고딕"/>
+                <a:cs typeface="무궁화 고딕"/>
+                <a:sym typeface="무궁화 고딕"/>
               </a:rPr>
               <a:t>스무고개</a:t>
             </a:r>
@@ -3189,8 +3185,8 @@
         </p:nvSpPr>
         <p:spPr>
           <a:xfrm rot="0">
-            <a:off x="15264803" y="9812655"/>
-            <a:ext cx="2637975" cy="474345"/>
+            <a:off x="14603066" y="9822180"/>
+            <a:ext cx="3299712" cy="464820"/>
           </a:xfrm>
           <a:prstGeom prst="rect">
             <a:avLst/>
@@ -3215,10 +3211,10 @@
                 <a:solidFill>
                   <a:srgbClr val="FFFFFF"/>
                 </a:solidFill>
-                <a:latin typeface="TDTD갬성명조"/>
-                <a:ea typeface="TDTD갬성명조"/>
-                <a:cs typeface="TDTD갬성명조"/>
-                <a:sym typeface="TDTD갬성명조"/>
+                <a:latin typeface="무궁화 고딕"/>
+                <a:ea typeface="무궁화 고딕"/>
+                <a:cs typeface="무궁화 고딕"/>
+                <a:sym typeface="무궁화 고딕"/>
               </a:rPr>
               <a:t>ⓒ 2026. Sunday Play</a:t>
             </a:r>
@@ -3265,8 +3261,8 @@
         </p:nvSpPr>
         <p:spPr>
           <a:xfrm rot="0">
-            <a:off x="3238925" y="4092795"/>
-            <a:ext cx="11810151" cy="2200275"/>
+            <a:off x="3238925" y="4378545"/>
+            <a:ext cx="11810151" cy="1914525"/>
           </a:xfrm>
           <a:prstGeom prst="rect">
             <a:avLst/>
@@ -3288,10 +3284,10 @@
                 <a:solidFill>
                   <a:srgbClr val="000000"/>
                 </a:solidFill>
-                <a:latin typeface="Jua"/>
-                <a:ea typeface="Jua"/>
-                <a:cs typeface="Jua"/>
-                <a:sym typeface="Jua"/>
+                <a:latin typeface="무궁화 고딕"/>
+                <a:ea typeface="무궁화 고딕"/>
+                <a:cs typeface="무궁화 고딕"/>
+                <a:sym typeface="무궁화 고딕"/>
               </a:rPr>
               <a:t>나라</a:t>
             </a:r>
@@ -3413,8 +3409,8 @@
         </p:nvSpPr>
         <p:spPr>
           <a:xfrm rot="0">
-            <a:off x="4421807" y="3895725"/>
-            <a:ext cx="9444385" cy="2200275"/>
+            <a:off x="4421807" y="4181475"/>
+            <a:ext cx="9444385" cy="1914525"/>
           </a:xfrm>
           <a:prstGeom prst="rect">
             <a:avLst/>
@@ -3436,10 +3432,10 @@
                 <a:solidFill>
                   <a:srgbClr val="000000"/>
                 </a:solidFill>
-                <a:latin typeface="Jua"/>
-                <a:ea typeface="Jua"/>
-                <a:cs typeface="Jua"/>
-                <a:sym typeface="Jua"/>
+                <a:latin typeface="무궁화 고딕"/>
+                <a:ea typeface="무궁화 고딕"/>
+                <a:cs typeface="무궁화 고딕"/>
+                <a:sym typeface="무궁화 고딕"/>
               </a:rPr>
               <a:t>감사합니다!</a:t>
             </a:r>
@@ -3638,8 +3634,8 @@
         </p:nvSpPr>
         <p:spPr>
           <a:xfrm rot="0">
-            <a:off x="11392761" y="600705"/>
-            <a:ext cx="5362043" cy="1600200"/>
+            <a:off x="11392761" y="819780"/>
+            <a:ext cx="5362043" cy="1381125"/>
           </a:xfrm>
           <a:prstGeom prst="rect">
             <a:avLst/>
@@ -3661,10 +3657,10 @@
                 <a:solidFill>
                   <a:srgbClr val="FFFAEF"/>
                 </a:solidFill>
-                <a:latin typeface="Jua"/>
-                <a:ea typeface="Jua"/>
-                <a:cs typeface="Jua"/>
-                <a:sym typeface="Jua"/>
+                <a:latin typeface="무궁화 고딕"/>
+                <a:ea typeface="무궁화 고딕"/>
+                <a:cs typeface="무궁화 고딕"/>
+                <a:sym typeface="무궁화 고딕"/>
               </a:rPr>
               <a:t>규칙</a:t>
             </a:r>
@@ -3680,9 +3676,9 @@
         <p:grpSpPr>
           <a:xfrm rot="0">
             <a:off x="309172" y="535073"/>
-            <a:ext cx="10694683" cy="2573620"/>
+            <a:ext cx="10694683" cy="2406534"/>
             <a:chOff x="0" y="0"/>
-            <a:chExt cx="14259577" cy="3431493"/>
+            <a:chExt cx="14259577" cy="3208711"/>
           </a:xfrm>
         </p:grpSpPr>
         <p:sp>
@@ -3693,8 +3689,8 @@
           </p:nvSpPr>
           <p:spPr>
             <a:xfrm rot="0">
-              <a:off x="0" y="1380584"/>
-              <a:ext cx="14259577" cy="2050910"/>
+              <a:off x="0" y="1388378"/>
+              <a:ext cx="14259577" cy="1820333"/>
             </a:xfrm>
             <a:prstGeom prst="rect">
               <a:avLst/>
@@ -3708,18 +3704,18 @@
             <a:p>
               <a:pPr algn="l">
                 <a:lnSpc>
-                  <a:spcPts val="6273"/>
+                  <a:spcPts val="5599"/>
                 </a:lnSpc>
               </a:pPr>
               <a:r>
-                <a:rPr lang="en-US" sz="4480">
+                <a:rPr lang="en-US" sz="3999">
                   <a:solidFill>
                     <a:srgbClr val="FFFAEF"/>
                   </a:solidFill>
-                  <a:latin typeface="TDTD가온"/>
-                  <a:ea typeface="TDTD가온"/>
-                  <a:cs typeface="TDTD가온"/>
-                  <a:sym typeface="TDTD가온"/>
+                  <a:latin typeface="무궁화 고딕"/>
+                  <a:ea typeface="무궁화 고딕"/>
+                  <a:cs typeface="무궁화 고딕"/>
+                  <a:sym typeface="무궁화 고딕"/>
                 </a:rPr>
                 <a:t>팀별 질문 순서를 정합니다.</a:t>
               </a:r>
@@ -3727,18 +3723,18 @@
             <a:p>
               <a:pPr algn="l">
                 <a:lnSpc>
-                  <a:spcPts val="6273"/>
+                  <a:spcPts val="5599"/>
                 </a:lnSpc>
               </a:pPr>
               <a:r>
-                <a:rPr lang="en-US" sz="4480">
+                <a:rPr lang="en-US" sz="3999">
                   <a:solidFill>
                     <a:srgbClr val="FFFAEF"/>
                   </a:solidFill>
-                  <a:latin typeface="TDTD가온"/>
-                  <a:ea typeface="TDTD가온"/>
-                  <a:cs typeface="TDTD가온"/>
-                  <a:sym typeface="TDTD가온"/>
+                  <a:latin typeface="무궁화 고딕"/>
+                  <a:ea typeface="무궁화 고딕"/>
+                  <a:cs typeface="무궁화 고딕"/>
+                  <a:sym typeface="무궁화 고딕"/>
                 </a:rPr>
                 <a:t>진행자가 정답을 정하고 카테고리를 알려줍니다.</a:t>
               </a:r>
@@ -3753,8 +3749,8 @@
           </p:nvSpPr>
           <p:spPr>
             <a:xfrm rot="0">
-              <a:off x="0" y="-171450"/>
-              <a:ext cx="9574913" cy="1169217"/>
+              <a:off x="0" y="-66675"/>
+              <a:ext cx="9574913" cy="1062712"/>
             </a:xfrm>
             <a:prstGeom prst="rect">
               <a:avLst/>
@@ -3776,10 +3772,10 @@
                   <a:solidFill>
                     <a:srgbClr val="FFFAEF"/>
                   </a:solidFill>
-                  <a:latin typeface="Jua"/>
-                  <a:ea typeface="Jua"/>
-                  <a:cs typeface="Jua"/>
-                  <a:sym typeface="Jua"/>
+                  <a:latin typeface="무궁화 고딕 Bold"/>
+                  <a:ea typeface="무궁화 고딕 Bold"/>
+                  <a:cs typeface="무궁화 고딕 Bold"/>
+                  <a:sym typeface="무궁화 고딕 Bold"/>
                 </a:rPr>
                 <a:t>STEP 1.</a:t>
               </a:r>
@@ -3796,9 +3792,9 @@
         <p:grpSpPr>
           <a:xfrm rot="0">
             <a:off x="10030747" y="7451103"/>
-            <a:ext cx="8086071" cy="2574122"/>
+            <a:ext cx="8086071" cy="2402712"/>
             <a:chOff x="0" y="0"/>
-            <a:chExt cx="10781428" cy="3432162"/>
+            <a:chExt cx="10781428" cy="3203616"/>
           </a:xfrm>
         </p:grpSpPr>
         <p:sp>
@@ -3809,8 +3805,8 @@
           </p:nvSpPr>
           <p:spPr>
             <a:xfrm rot="0">
-              <a:off x="0" y="1377534"/>
-              <a:ext cx="10616599" cy="2054628"/>
+              <a:off x="0" y="1373758"/>
+              <a:ext cx="10616599" cy="1829858"/>
             </a:xfrm>
             <a:prstGeom prst="rect">
               <a:avLst/>
@@ -3824,18 +3820,18 @@
             <a:p>
               <a:pPr algn="l">
                 <a:lnSpc>
-                  <a:spcPts val="6284"/>
+                  <a:spcPts val="5600"/>
                 </a:lnSpc>
               </a:pPr>
               <a:r>
-                <a:rPr lang="en-US" sz="4489">
+                <a:rPr lang="en-US" sz="4000">
                   <a:solidFill>
                     <a:srgbClr val="FFFAEF"/>
                   </a:solidFill>
-                  <a:latin typeface="TDTD가온"/>
-                  <a:ea typeface="TDTD가온"/>
-                  <a:cs typeface="TDTD가온"/>
-                  <a:sym typeface="TDTD가온"/>
+                  <a:latin typeface="무궁화 고딕"/>
+                  <a:ea typeface="무궁화 고딕"/>
+                  <a:cs typeface="무궁화 고딕"/>
+                  <a:sym typeface="무궁화 고딕"/>
                 </a:rPr>
                 <a:t>20번 안에 먼저 정답을 맞춘 팀이 점수!</a:t>
               </a:r>
@@ -3843,18 +3839,18 @@
             <a:p>
               <a:pPr algn="l">
                 <a:lnSpc>
-                  <a:spcPts val="6284"/>
+                  <a:spcPts val="5600"/>
                 </a:lnSpc>
               </a:pPr>
               <a:r>
-                <a:rPr lang="en-US" sz="4489">
+                <a:rPr lang="en-US" sz="4000">
                   <a:solidFill>
                     <a:srgbClr val="FFFAEF"/>
                   </a:solidFill>
-                  <a:latin typeface="TDTD가온"/>
-                  <a:ea typeface="TDTD가온"/>
-                  <a:cs typeface="TDTD가온"/>
-                  <a:sym typeface="TDTD가온"/>
+                  <a:latin typeface="무궁화 고딕"/>
+                  <a:ea typeface="무궁화 고딕"/>
+                  <a:cs typeface="무궁화 고딕"/>
+                  <a:sym typeface="무궁화 고딕"/>
                 </a:rPr>
                 <a:t>가장 많은 점수를 얻은 팀이 우승합니다.</a:t>
               </a:r>
@@ -3869,8 +3865,8 @@
           </p:nvSpPr>
           <p:spPr>
             <a:xfrm rot="0">
-              <a:off x="0" y="-171450"/>
-              <a:ext cx="10781428" cy="1171105"/>
+              <a:off x="0" y="-57150"/>
+              <a:ext cx="10781428" cy="1053029"/>
             </a:xfrm>
             <a:prstGeom prst="rect">
               <a:avLst/>
@@ -3892,10 +3888,10 @@
                   <a:solidFill>
                     <a:srgbClr val="FFFAEF"/>
                   </a:solidFill>
-                  <a:latin typeface="Jua"/>
-                  <a:ea typeface="Jua"/>
-                  <a:cs typeface="Jua"/>
-                  <a:sym typeface="Jua"/>
+                  <a:latin typeface="무궁화 고딕 Bold"/>
+                  <a:ea typeface="무궁화 고딕 Bold"/>
+                  <a:cs typeface="무궁화 고딕 Bold"/>
+                  <a:sym typeface="무궁화 고딕 Bold"/>
                 </a:rPr>
                 <a:t>STEP 3.</a:t>
               </a:r>
@@ -3911,10 +3907,10 @@
         </p:nvGrpSpPr>
         <p:grpSpPr>
           <a:xfrm rot="0">
-            <a:off x="4621704" y="3858476"/>
-            <a:ext cx="8612946" cy="2570047"/>
+            <a:off x="4621704" y="3995224"/>
+            <a:ext cx="8612946" cy="2402261"/>
             <a:chOff x="0" y="0"/>
-            <a:chExt cx="11483928" cy="3426730"/>
+            <a:chExt cx="11483928" cy="3203015"/>
           </a:xfrm>
         </p:grpSpPr>
         <p:sp>
@@ -3925,8 +3921,8 @@
           </p:nvSpPr>
           <p:spPr>
             <a:xfrm rot="0">
-              <a:off x="0" y="1375218"/>
-              <a:ext cx="11483928" cy="2051512"/>
+              <a:off x="0" y="1382681"/>
+              <a:ext cx="11483928" cy="1820333"/>
             </a:xfrm>
             <a:prstGeom prst="rect">
               <a:avLst/>
@@ -3940,18 +3936,18 @@
             <a:p>
               <a:pPr algn="l">
                 <a:lnSpc>
-                  <a:spcPts val="6275"/>
+                  <a:spcPts val="5599"/>
                 </a:lnSpc>
               </a:pPr>
               <a:r>
-                <a:rPr lang="en-US" sz="4482">
+                <a:rPr lang="en-US" sz="3999">
                   <a:solidFill>
                     <a:srgbClr val="FFFAEF"/>
                   </a:solidFill>
-                  <a:latin typeface="TDTD가온"/>
-                  <a:ea typeface="TDTD가온"/>
-                  <a:cs typeface="TDTD가온"/>
-                  <a:sym typeface="TDTD가온"/>
+                  <a:latin typeface="무궁화 고딕"/>
+                  <a:ea typeface="무궁화 고딕"/>
+                  <a:cs typeface="무궁화 고딕"/>
+                  <a:sym typeface="무궁화 고딕"/>
                 </a:rPr>
                 <a:t>팀별로 돌아가며 질문합니다.</a:t>
               </a:r>
@@ -3959,18 +3955,18 @@
             <a:p>
               <a:pPr algn="l">
                 <a:lnSpc>
-                  <a:spcPts val="6275"/>
+                  <a:spcPts val="5599"/>
                 </a:lnSpc>
               </a:pPr>
               <a:r>
-                <a:rPr lang="en-US" sz="4482">
+                <a:rPr lang="en-US" sz="3999">
                   <a:solidFill>
                     <a:srgbClr val="FFFAEF"/>
                   </a:solidFill>
-                  <a:latin typeface="TDTD가온"/>
-                  <a:ea typeface="TDTD가온"/>
-                  <a:cs typeface="TDTD가온"/>
-                  <a:sym typeface="TDTD가온"/>
+                  <a:latin typeface="무궁화 고딕"/>
+                  <a:ea typeface="무궁화 고딕"/>
+                  <a:cs typeface="무궁화 고딕"/>
+                  <a:sym typeface="무궁화 고딕"/>
                 </a:rPr>
                 <a:t>진행자는 "예" 또는 "아니오"로만 대답!</a:t>
               </a:r>
@@ -3985,8 +3981,8 @@
           </p:nvSpPr>
           <p:spPr>
             <a:xfrm rot="0">
-              <a:off x="0" y="-171450"/>
-              <a:ext cx="7079955" cy="1169523"/>
+              <a:off x="0" y="-57150"/>
+              <a:ext cx="7079955" cy="1053161"/>
             </a:xfrm>
             <a:prstGeom prst="rect">
               <a:avLst/>
@@ -4008,10 +4004,10 @@
                   <a:solidFill>
                     <a:srgbClr val="FFFAEF"/>
                   </a:solidFill>
-                  <a:latin typeface="Jua"/>
-                  <a:ea typeface="Jua"/>
-                  <a:cs typeface="Jua"/>
-                  <a:sym typeface="Jua"/>
+                  <a:latin typeface="무궁화 고딕 Bold"/>
+                  <a:ea typeface="무궁화 고딕 Bold"/>
+                  <a:cs typeface="무궁화 고딕 Bold"/>
+                  <a:sym typeface="무궁화 고딕 Bold"/>
                 </a:rPr>
                 <a:t>STEP 2.</a:t>
               </a:r>
@@ -4059,8 +4055,8 @@
         </p:nvSpPr>
         <p:spPr>
           <a:xfrm rot="0">
-            <a:off x="3238925" y="4092795"/>
-            <a:ext cx="11810151" cy="2200275"/>
+            <a:off x="3238925" y="4378545"/>
+            <a:ext cx="11810151" cy="1914525"/>
           </a:xfrm>
           <a:prstGeom prst="rect">
             <a:avLst/>
@@ -4082,10 +4078,10 @@
                 <a:solidFill>
                   <a:srgbClr val="000000"/>
                 </a:solidFill>
-                <a:latin typeface="Jua"/>
-                <a:ea typeface="Jua"/>
-                <a:cs typeface="Jua"/>
-                <a:sym typeface="Jua"/>
+                <a:latin typeface="무궁화 고딕"/>
+                <a:ea typeface="무궁화 고딕"/>
+                <a:cs typeface="무궁화 고딕"/>
+                <a:sym typeface="무궁화 고딕"/>
               </a:rPr>
               <a:t>팀을 나눠주세요!</a:t>
             </a:r>
@@ -4232,8 +4228,8 @@
         </p:nvSpPr>
         <p:spPr>
           <a:xfrm rot="0">
-            <a:off x="1028700" y="3892867"/>
-            <a:ext cx="15555091" cy="2200275"/>
+            <a:off x="1028700" y="4178617"/>
+            <a:ext cx="15555091" cy="1914525"/>
           </a:xfrm>
           <a:prstGeom prst="rect">
             <a:avLst/>
@@ -4255,10 +4251,10 @@
                 <a:solidFill>
                   <a:srgbClr val="FFFAEF"/>
                 </a:solidFill>
-                <a:latin typeface="Jua"/>
-                <a:ea typeface="Jua"/>
-                <a:cs typeface="Jua"/>
-                <a:sym typeface="Jua"/>
+                <a:latin typeface="무궁화 고딕"/>
+                <a:ea typeface="무궁화 고딕"/>
+                <a:cs typeface="무궁화 고딕"/>
+                <a:sym typeface="무궁화 고딕"/>
               </a:rPr>
               <a:t>스무고개</a:t>
             </a:r>
@@ -4273,8 +4269,8 @@
         </p:nvSpPr>
         <p:spPr>
           <a:xfrm rot="0">
-            <a:off x="15264803" y="9812655"/>
-            <a:ext cx="2637975" cy="474345"/>
+            <a:off x="14603066" y="9822180"/>
+            <a:ext cx="3299712" cy="464820"/>
           </a:xfrm>
           <a:prstGeom prst="rect">
             <a:avLst/>
@@ -4299,10 +4295,10 @@
                 <a:solidFill>
                   <a:srgbClr val="FFFFFF"/>
                 </a:solidFill>
-                <a:latin typeface="TDTD갬성명조"/>
-                <a:ea typeface="TDTD갬성명조"/>
-                <a:cs typeface="TDTD갬성명조"/>
-                <a:sym typeface="TDTD갬성명조"/>
+                <a:latin typeface="무궁화 고딕"/>
+                <a:ea typeface="무궁화 고딕"/>
+                <a:cs typeface="무궁화 고딕"/>
+                <a:sym typeface="무궁화 고딕"/>
               </a:rPr>
               <a:t>ⓒ 2026. Sunday Play</a:t>
             </a:r>
@@ -4349,8 +4345,8 @@
         </p:nvSpPr>
         <p:spPr>
           <a:xfrm rot="0">
-            <a:off x="3238925" y="4092795"/>
-            <a:ext cx="11810151" cy="2200275"/>
+            <a:off x="3238925" y="4378545"/>
+            <a:ext cx="11810151" cy="1914525"/>
           </a:xfrm>
           <a:prstGeom prst="rect">
             <a:avLst/>
@@ -4372,10 +4368,10 @@
                 <a:solidFill>
                   <a:srgbClr val="000000"/>
                 </a:solidFill>
-                <a:latin typeface="Jua"/>
-                <a:ea typeface="Jua"/>
-                <a:cs typeface="Jua"/>
-                <a:sym typeface="Jua"/>
+                <a:latin typeface="무궁화 고딕"/>
+                <a:ea typeface="무궁화 고딕"/>
+                <a:cs typeface="무궁화 고딕"/>
+                <a:sym typeface="무궁화 고딕"/>
               </a:rPr>
               <a:t>동물</a:t>
             </a:r>
@@ -4472,8 +4468,8 @@
         </p:nvSpPr>
         <p:spPr>
           <a:xfrm rot="0">
-            <a:off x="3238925" y="4092795"/>
-            <a:ext cx="11810151" cy="2200275"/>
+            <a:off x="3238925" y="4378545"/>
+            <a:ext cx="11810151" cy="1914525"/>
           </a:xfrm>
           <a:prstGeom prst="rect">
             <a:avLst/>
@@ -4495,10 +4491,10 @@
                 <a:solidFill>
                   <a:srgbClr val="000000"/>
                 </a:solidFill>
-                <a:latin typeface="Jua"/>
-                <a:ea typeface="Jua"/>
-                <a:cs typeface="Jua"/>
-                <a:sym typeface="Jua"/>
+                <a:latin typeface="무궁화 고딕"/>
+                <a:ea typeface="무궁화 고딕"/>
+                <a:cs typeface="무궁화 고딕"/>
+                <a:sym typeface="무궁화 고딕"/>
               </a:rPr>
               <a:t>음식</a:t>
             </a:r>
@@ -4595,8 +4591,8 @@
         </p:nvSpPr>
         <p:spPr>
           <a:xfrm rot="0">
-            <a:off x="3238925" y="4092795"/>
-            <a:ext cx="11810151" cy="2200275"/>
+            <a:off x="3238925" y="4378545"/>
+            <a:ext cx="11810151" cy="1914525"/>
           </a:xfrm>
           <a:prstGeom prst="rect">
             <a:avLst/>
@@ -4618,10 +4614,10 @@
                 <a:solidFill>
                   <a:srgbClr val="000000"/>
                 </a:solidFill>
-                <a:latin typeface="Jua"/>
-                <a:ea typeface="Jua"/>
-                <a:cs typeface="Jua"/>
-                <a:sym typeface="Jua"/>
+                <a:latin typeface="무궁화 고딕"/>
+                <a:ea typeface="무궁화 고딕"/>
+                <a:cs typeface="무궁화 고딕"/>
+                <a:sym typeface="무궁화 고딕"/>
               </a:rPr>
               <a:t>사물</a:t>
             </a:r>
@@ -4718,8 +4714,8 @@
         </p:nvSpPr>
         <p:spPr>
           <a:xfrm rot="0">
-            <a:off x="3238925" y="4092795"/>
-            <a:ext cx="11810151" cy="2200275"/>
+            <a:off x="3238925" y="4378545"/>
+            <a:ext cx="11810151" cy="1914525"/>
           </a:xfrm>
           <a:prstGeom prst="rect">
             <a:avLst/>
@@ -4741,10 +4737,10 @@
                 <a:solidFill>
                   <a:srgbClr val="000000"/>
                 </a:solidFill>
-                <a:latin typeface="Jua"/>
-                <a:ea typeface="Jua"/>
-                <a:cs typeface="Jua"/>
-                <a:sym typeface="Jua"/>
+                <a:latin typeface="무궁화 고딕"/>
+                <a:ea typeface="무궁화 고딕"/>
+                <a:cs typeface="무궁화 고딕"/>
+                <a:sym typeface="무궁화 고딕"/>
               </a:rPr>
               <a:t>직업</a:t>
             </a:r>
@@ -4841,8 +4837,8 @@
         </p:nvSpPr>
         <p:spPr>
           <a:xfrm rot="0">
-            <a:off x="3238925" y="4092795"/>
-            <a:ext cx="11810151" cy="2200275"/>
+            <a:off x="3238925" y="4378545"/>
+            <a:ext cx="11810151" cy="1914525"/>
           </a:xfrm>
           <a:prstGeom prst="rect">
             <a:avLst/>
@@ -4864,10 +4860,10 @@
                 <a:solidFill>
                   <a:srgbClr val="000000"/>
                 </a:solidFill>
-                <a:latin typeface="Jua"/>
-                <a:ea typeface="Jua"/>
-                <a:cs typeface="Jua"/>
-                <a:sym typeface="Jua"/>
+                <a:latin typeface="무궁화 고딕"/>
+                <a:ea typeface="무궁화 고딕"/>
+                <a:cs typeface="무궁화 고딕"/>
+                <a:sym typeface="무궁화 고딕"/>
               </a:rPr>
               <a:t>인물</a:t>
             </a:r>

</xml_diff>